<commit_message>
Finitions de la présentation
</commit_message>
<xml_diff>
--- a/Chaumaz_Ludovic_6_presentation_102025.pptx
+++ b/Chaumaz_Ludovic_6_presentation_102025.pptx
@@ -5,7 +5,7 @@
     <p:sldMasterId id="2147483672" r:id="rId1"/>
   </p:sldMasterIdLst>
   <p:notesMasterIdLst>
-    <p:notesMasterId r:id="rId21"/>
+    <p:notesMasterId r:id="rId22"/>
   </p:notesMasterIdLst>
   <p:sldIdLst>
     <p:sldId id="257" r:id="rId2"/>
@@ -27,6 +27,7 @@
     <p:sldId id="267" r:id="rId18"/>
     <p:sldId id="268" r:id="rId19"/>
     <p:sldId id="269" r:id="rId20"/>
+    <p:sldId id="276" r:id="rId21"/>
   </p:sldIdLst>
   <p:sldSz cx="12192000" cy="6858000"/>
   <p:notesSz cx="6858000" cy="9144000"/>
@@ -215,7 +216,7 @@
           <a:p>
             <a:fld id="{73FE8E35-F60A-4488-AAF8-000CBC3CB0C8}" type="datetimeFigureOut">
               <a:rPr lang="fr-FR" smtClean="0"/>
-              <a:t>12/12/2025</a:t>
+              <a:t>09/01/2026</a:t>
             </a:fld>
             <a:endParaRPr lang="fr-FR"/>
           </a:p>
@@ -727,7 +728,7 @@
           <a:p>
             <a:fld id="{85A8AEA9-4A83-4514-8314-CAAC6BB424E7}" type="datetime1">
               <a:rPr lang="fr-FR" smtClean="0"/>
-              <a:t>12/12/2025</a:t>
+              <a:t>09/01/2026</a:t>
             </a:fld>
             <a:endParaRPr lang="fr-FR"/>
           </a:p>
@@ -989,7 +990,7 @@
           <a:p>
             <a:fld id="{B098F633-EE6D-44A7-9E75-72C2FD5B7BAB}" type="datetime1">
               <a:rPr lang="fr-FR" smtClean="0"/>
-              <a:t>12/12/2025</a:t>
+              <a:t>09/01/2026</a:t>
             </a:fld>
             <a:endParaRPr lang="fr-FR"/>
           </a:p>
@@ -1224,7 +1225,7 @@
           <a:p>
             <a:fld id="{D1404B51-B437-4C22-9E27-0FFAA42698D9}" type="datetime1">
               <a:rPr lang="fr-FR" smtClean="0"/>
-              <a:t>12/12/2025</a:t>
+              <a:t>09/01/2026</a:t>
             </a:fld>
             <a:endParaRPr lang="fr-FR"/>
           </a:p>
@@ -1464,7 +1465,7 @@
           <a:p>
             <a:fld id="{65D6E619-AA96-4370-814B-B7263EDE5BEE}" type="datetime1">
               <a:rPr lang="fr-FR" smtClean="0"/>
-              <a:t>12/12/2025</a:t>
+              <a:t>09/01/2026</a:t>
             </a:fld>
             <a:endParaRPr lang="fr-FR"/>
           </a:p>
@@ -1771,7 +1772,7 @@
           <a:p>
             <a:fld id="{207AFFE8-C243-437F-ACCD-2DE4DA4F5631}" type="datetime1">
               <a:rPr lang="fr-FR" smtClean="0"/>
-              <a:t>12/12/2025</a:t>
+              <a:t>09/01/2026</a:t>
             </a:fld>
             <a:endParaRPr lang="fr-FR"/>
           </a:p>
@@ -2073,7 +2074,7 @@
           <a:p>
             <a:fld id="{09D56D03-5254-4E0A-91BD-3F14E781E4E2}" type="datetime1">
               <a:rPr lang="fr-FR" smtClean="0"/>
-              <a:t>12/12/2025</a:t>
+              <a:t>09/01/2026</a:t>
             </a:fld>
             <a:endParaRPr lang="fr-FR"/>
           </a:p>
@@ -2495,7 +2496,7 @@
           <a:p>
             <a:fld id="{0C393EB4-4823-4B53-B0B9-58F9E25A8EE9}" type="datetime1">
               <a:rPr lang="fr-FR" smtClean="0"/>
-              <a:t>12/12/2025</a:t>
+              <a:t>09/01/2026</a:t>
             </a:fld>
             <a:endParaRPr lang="fr-FR"/>
           </a:p>
@@ -2590,7 +2591,7 @@
           <a:p>
             <a:fld id="{E9058721-5E39-4BBC-9BF8-C6E60922CA88}" type="datetime1">
               <a:rPr lang="fr-FR" smtClean="0"/>
-              <a:t>12/12/2025</a:t>
+              <a:t>09/01/2026</a:t>
             </a:fld>
             <a:endParaRPr lang="fr-FR"/>
           </a:p>
@@ -2752,7 +2753,7 @@
           <a:p>
             <a:fld id="{745F4260-FCD6-49A1-B353-AD20383AEFA7}" type="datetime1">
               <a:rPr lang="fr-FR" smtClean="0"/>
-              <a:t>12/12/2025</a:t>
+              <a:t>09/01/2026</a:t>
             </a:fld>
             <a:endParaRPr lang="fr-FR"/>
           </a:p>
@@ -3130,7 +3131,7 @@
           <a:p>
             <a:fld id="{28C70CC8-C2E2-4F25-AD41-5746C43C3AF6}" type="datetime1">
               <a:rPr lang="fr-FR" smtClean="0"/>
-              <a:t>12/12/2025</a:t>
+              <a:t>09/01/2026</a:t>
             </a:fld>
             <a:endParaRPr lang="fr-FR"/>
           </a:p>
@@ -3419,7 +3420,7 @@
           <a:p>
             <a:fld id="{C61480EA-1F7B-4118-88E7-7DD22ACFAD7A}" type="datetime1">
               <a:rPr lang="fr-FR" smtClean="0"/>
-              <a:t>12/12/2025</a:t>
+              <a:t>09/01/2026</a:t>
             </a:fld>
             <a:endParaRPr lang="fr-FR"/>
           </a:p>
@@ -3630,7 +3631,7 @@
           <a:p>
             <a:fld id="{C366350D-C3F6-47FE-AE80-E681493CF550}" type="datetime1">
               <a:rPr lang="fr-FR" smtClean="0"/>
-              <a:t>12/12/2025</a:t>
+              <a:t>09/01/2026</a:t>
             </a:fld>
             <a:endParaRPr lang="fr-FR"/>
           </a:p>
@@ -4374,7 +4375,7 @@
                   <a:schemeClr val="bg1"/>
                 </a:solidFill>
               </a:rPr>
-              <a:t>05/12/25</a:t>
+              <a:t>16/01/26</a:t>
             </a:r>
           </a:p>
         </p:txBody>
@@ -7322,13 +7323,13 @@
         <p:spPr>
           <a:xfrm>
             <a:off x="8898464" y="3786434"/>
-            <a:ext cx="1241045" cy="646331"/>
+            <a:ext cx="1157689" cy="646331"/>
           </a:xfrm>
           <a:prstGeom prst="rect">
             <a:avLst/>
           </a:prstGeom>
           <a:solidFill>
-            <a:srgbClr val="00B0F0"/>
+            <a:srgbClr val="FFC000"/>
           </a:solidFill>
           <a:ln w="38100">
             <a:solidFill>
@@ -7344,13 +7345,13 @@
           <a:p>
             <a:r>
               <a:rPr lang="fr-FR" dirty="0"/>
-              <a:t>Application</a:t>
+              <a:t>Notebook</a:t>
             </a:r>
           </a:p>
           <a:p>
             <a:r>
               <a:rPr lang="fr-FR" dirty="0"/>
-              <a:t>finale</a:t>
+              <a:t>test</a:t>
             </a:r>
           </a:p>
         </p:txBody>
@@ -8207,7 +8208,7 @@
         <p:spPr>
           <a:xfrm flipV="1">
             <a:off x="4258179" y="4432765"/>
-            <a:ext cx="5260808" cy="1399998"/>
+            <a:ext cx="5219130" cy="1399998"/>
           </a:xfrm>
           <a:prstGeom prst="bentConnector2">
             <a:avLst/>
@@ -8651,40 +8652,70 @@
           </a:p>
         </p:txBody>
       </p:sp>
-      <p:sp>
-        <p:nvSpPr>
-          <p:cNvPr id="9" name="Espace réservé du contenu 8">
-            <a:extLst>
-              <a:ext uri="{FF2B5EF4-FFF2-40B4-BE49-F238E27FC236}">
-                <a16:creationId xmlns:a16="http://schemas.microsoft.com/office/drawing/2014/main" id="{761B2BC9-C5A0-CE2D-B6D3-7373087A63C7}"/>
-              </a:ext>
-            </a:extLst>
-          </p:cNvPr>
-          <p:cNvSpPr>
-            <a:spLocks noGrp="1"/>
-          </p:cNvSpPr>
-          <p:nvPr>
-            <p:ph idx="1"/>
-          </p:nvPr>
-        </p:nvSpPr>
-        <p:spPr/>
-        <p:txBody>
-          <a:bodyPr>
-            <a:normAutofit/>
-          </a:bodyPr>
-          <a:lstStyle/>
-          <a:p>
-            <a:pPr algn="ctr"/>
-            <a:r>
-              <a:rPr lang="fr-FR" sz="2400" dirty="0">
-                <a:hlinkClick r:id="rId2"/>
-              </a:rPr>
-              <a:t>Cliquez ici !</a:t>
-            </a:r>
-            <a:endParaRPr lang="fr-FR" sz="2400" dirty="0"/>
-          </a:p>
-        </p:txBody>
-      </p:sp>
+      <p:pic>
+        <p:nvPicPr>
+          <p:cNvPr id="8" name="Espace réservé du contenu 7" descr="Une image contenant texte, capture d’écran, Police, ligne&#10;&#10;Le contenu généré par l’IA peut être incorrect.">
+            <a:extLst>
+              <a:ext uri="{FF2B5EF4-FFF2-40B4-BE49-F238E27FC236}">
+                <a16:creationId xmlns:a16="http://schemas.microsoft.com/office/drawing/2014/main" id="{8DEB563F-22BA-F9E9-3E22-5ED9AF846D52}"/>
+              </a:ext>
+            </a:extLst>
+          </p:cNvPr>
+          <p:cNvPicPr>
+            <a:picLocks noGrp="1" noChangeAspect="1"/>
+          </p:cNvPicPr>
+          <p:nvPr>
+            <p:ph sz="half" idx="1"/>
+          </p:nvPr>
+        </p:nvPicPr>
+        <p:blipFill>
+          <a:blip r:embed="rId2"/>
+          <a:stretch>
+            <a:fillRect/>
+          </a:stretch>
+        </p:blipFill>
+        <p:spPr>
+          <a:xfrm>
+            <a:off x="1091893" y="3796472"/>
+            <a:ext cx="4401164" cy="495369"/>
+          </a:xfrm>
+          <a:prstGeom prst="rect">
+            <a:avLst/>
+          </a:prstGeom>
+        </p:spPr>
+      </p:pic>
+      <p:pic>
+        <p:nvPicPr>
+          <p:cNvPr id="11" name="Espace réservé du contenu 10">
+            <a:extLst>
+              <a:ext uri="{FF2B5EF4-FFF2-40B4-BE49-F238E27FC236}">
+                <a16:creationId xmlns:a16="http://schemas.microsoft.com/office/drawing/2014/main" id="{03C220AB-BA07-4D17-E7DF-B83709E0CBC1}"/>
+              </a:ext>
+            </a:extLst>
+          </p:cNvPr>
+          <p:cNvPicPr>
+            <a:picLocks noGrp="1" noChangeAspect="1"/>
+          </p:cNvPicPr>
+          <p:nvPr>
+            <p:ph sz="half" idx="2"/>
+          </p:nvPr>
+        </p:nvPicPr>
+        <p:blipFill>
+          <a:blip r:embed="rId3"/>
+          <a:stretch>
+            <a:fillRect/>
+          </a:stretch>
+        </p:blipFill>
+        <p:spPr>
+          <a:xfrm>
+            <a:off x="7303865" y="3815524"/>
+            <a:ext cx="3191320" cy="457264"/>
+          </a:xfrm>
+          <a:prstGeom prst="rect">
+            <a:avLst/>
+          </a:prstGeom>
+        </p:spPr>
+      </p:pic>
       <p:sp>
         <p:nvSpPr>
           <p:cNvPr id="5" name="Espace réservé du numéro de diapositive 4">
@@ -8843,6 +8874,51 @@
           </a:p>
         </p:txBody>
       </p:sp>
+      <p:cxnSp>
+        <p:nvCxnSpPr>
+          <p:cNvPr id="13" name="Connecteur droit avec flèche 12">
+            <a:extLst>
+              <a:ext uri="{FF2B5EF4-FFF2-40B4-BE49-F238E27FC236}">
+                <a16:creationId xmlns:a16="http://schemas.microsoft.com/office/drawing/2014/main" id="{2488C55B-E5A9-3028-BD72-82E4CBA1D291}"/>
+              </a:ext>
+            </a:extLst>
+          </p:cNvPr>
+          <p:cNvCxnSpPr>
+            <a:stCxn id="8" idx="3"/>
+            <a:endCxn id="11" idx="1"/>
+          </p:cNvCxnSpPr>
+          <p:nvPr/>
+        </p:nvCxnSpPr>
+        <p:spPr>
+          <a:xfrm flipV="1">
+            <a:off x="5493057" y="4044156"/>
+            <a:ext cx="1810808" cy="1"/>
+          </a:xfrm>
+          <a:prstGeom prst="straightConnector1">
+            <a:avLst/>
+          </a:prstGeom>
+          <a:ln w="28575">
+            <a:solidFill>
+              <a:schemeClr val="tx1"/>
+            </a:solidFill>
+            <a:tailEnd type="triangle"/>
+          </a:ln>
+        </p:spPr>
+        <p:style>
+          <a:lnRef idx="1">
+            <a:schemeClr val="accent1"/>
+          </a:lnRef>
+          <a:fillRef idx="0">
+            <a:schemeClr val="accent1"/>
+          </a:fillRef>
+          <a:effectRef idx="0">
+            <a:schemeClr val="accent1"/>
+          </a:effectRef>
+          <a:fontRef idx="minor">
+            <a:schemeClr val="tx1"/>
+          </a:fontRef>
+        </p:style>
+      </p:cxnSp>
     </p:spTree>
     <p:extLst>
       <p:ext uri="{BB962C8B-B14F-4D97-AF65-F5344CB8AC3E}">
@@ -9139,6 +9215,274 @@
     <p:extLst>
       <p:ext uri="{BB962C8B-B14F-4D97-AF65-F5344CB8AC3E}">
         <p14:creationId xmlns:p14="http://schemas.microsoft.com/office/powerpoint/2010/main" val="3466016859"/>
+      </p:ext>
+    </p:extLst>
+  </p:cSld>
+  <p:clrMapOvr>
+    <a:masterClrMapping/>
+  </p:clrMapOvr>
+</p:sld>
+</file>
+
+<file path=ppt/slides/slide20.xml><?xml version="1.0" encoding="utf-8"?>
+<p:sld xmlns:a="http://schemas.openxmlformats.org/drawingml/2006/main" xmlns:r="http://schemas.openxmlformats.org/officeDocument/2006/relationships" xmlns:p="http://schemas.openxmlformats.org/presentationml/2006/main">
+  <p:cSld>
+    <p:spTree>
+      <p:nvGrpSpPr>
+        <p:cNvPr id="1" name="">
+          <a:extLst>
+            <a:ext uri="{FF2B5EF4-FFF2-40B4-BE49-F238E27FC236}">
+              <a16:creationId xmlns:a16="http://schemas.microsoft.com/office/drawing/2014/main" id="{6909D75E-AFD8-A565-32EC-876B1CCFF1C4}"/>
+            </a:ext>
+          </a:extLst>
+        </p:cNvPr>
+        <p:cNvGrpSpPr/>
+        <p:nvPr/>
+      </p:nvGrpSpPr>
+      <p:grpSpPr>
+        <a:xfrm>
+          <a:off x="0" y="0"/>
+          <a:ext cx="0" cy="0"/>
+          <a:chOff x="0" y="0"/>
+          <a:chExt cx="0" cy="0"/>
+        </a:xfrm>
+      </p:grpSpPr>
+      <p:sp>
+        <p:nvSpPr>
+          <p:cNvPr id="2" name="Titre 1">
+            <a:extLst>
+              <a:ext uri="{FF2B5EF4-FFF2-40B4-BE49-F238E27FC236}">
+                <a16:creationId xmlns:a16="http://schemas.microsoft.com/office/drawing/2014/main" id="{4E7B8DAA-4C2E-2986-BADF-F25EB12EA47F}"/>
+              </a:ext>
+            </a:extLst>
+          </p:cNvPr>
+          <p:cNvSpPr>
+            <a:spLocks noGrp="1"/>
+          </p:cNvSpPr>
+          <p:nvPr>
+            <p:ph type="title"/>
+          </p:nvPr>
+        </p:nvSpPr>
+        <p:spPr/>
+        <p:txBody>
+          <a:bodyPr/>
+          <a:lstStyle/>
+          <a:p>
+            <a:r>
+              <a:rPr lang="fr-FR" dirty="0"/>
+              <a:t>Conclusion : Utilisation de l’API pour un </a:t>
+            </a:r>
+            <a:r>
+              <a:rPr lang="fr-FR" dirty="0" err="1"/>
+              <a:t>dashboard</a:t>
+            </a:r>
+            <a:br>
+              <a:rPr lang="fr-FR" dirty="0"/>
+            </a:br>
+            <a:r>
+              <a:rPr lang="fr-FR" dirty="0">
+                <a:sym typeface="Wingdings" panose="05000000000000000000" pitchFamily="2" charset="2"/>
+              </a:rPr>
+              <a:t> A suivre dans le projet 8 !</a:t>
+            </a:r>
+            <a:endParaRPr lang="fr-FR" dirty="0"/>
+          </a:p>
+        </p:txBody>
+      </p:sp>
+      <p:pic>
+        <p:nvPicPr>
+          <p:cNvPr id="8" name="Espace réservé du contenu 7">
+            <a:extLst>
+              <a:ext uri="{FF2B5EF4-FFF2-40B4-BE49-F238E27FC236}">
+                <a16:creationId xmlns:a16="http://schemas.microsoft.com/office/drawing/2014/main" id="{5CDD9754-494D-1B3A-0618-96827C18C6C7}"/>
+              </a:ext>
+            </a:extLst>
+          </p:cNvPr>
+          <p:cNvPicPr>
+            <a:picLocks noGrp="1" noChangeAspect="1"/>
+          </p:cNvPicPr>
+          <p:nvPr>
+            <p:ph idx="1"/>
+          </p:nvPr>
+        </p:nvPicPr>
+        <p:blipFill>
+          <a:blip r:embed="rId2"/>
+          <a:stretch>
+            <a:fillRect/>
+          </a:stretch>
+        </p:blipFill>
+        <p:spPr>
+          <a:xfrm>
+            <a:off x="1456956" y="2181225"/>
+            <a:ext cx="9278088" cy="3678238"/>
+          </a:xfrm>
+          <a:prstGeom prst="rect">
+            <a:avLst/>
+          </a:prstGeom>
+        </p:spPr>
+      </p:pic>
+      <p:sp>
+        <p:nvSpPr>
+          <p:cNvPr id="5" name="Espace réservé du numéro de diapositive 4">
+            <a:extLst>
+              <a:ext uri="{FF2B5EF4-FFF2-40B4-BE49-F238E27FC236}">
+                <a16:creationId xmlns:a16="http://schemas.microsoft.com/office/drawing/2014/main" id="{F4722C66-4A2C-FB58-F208-478AFCEB2BE5}"/>
+              </a:ext>
+            </a:extLst>
+          </p:cNvPr>
+          <p:cNvSpPr>
+            <a:spLocks noGrp="1"/>
+          </p:cNvSpPr>
+          <p:nvPr>
+            <p:ph type="sldNum" sz="quarter" idx="12"/>
+          </p:nvPr>
+        </p:nvSpPr>
+        <p:spPr/>
+        <p:txBody>
+          <a:bodyPr/>
+          <a:lstStyle/>
+          <a:p>
+            <a:fld id="{682819AE-B619-487D-9152-CB0FE4E70819}" type="slidenum">
+              <a:rPr lang="fr-FR" smtClean="0"/>
+              <a:t>20</a:t>
+            </a:fld>
+            <a:endParaRPr lang="fr-FR"/>
+          </a:p>
+        </p:txBody>
+      </p:sp>
+      <p:sp>
+        <p:nvSpPr>
+          <p:cNvPr id="4" name="ZoneTexte 3">
+            <a:extLst>
+              <a:ext uri="{FF2B5EF4-FFF2-40B4-BE49-F238E27FC236}">
+                <a16:creationId xmlns:a16="http://schemas.microsoft.com/office/drawing/2014/main" id="{C2DEA719-CA2C-CF92-0F7C-E764234ADC73}"/>
+              </a:ext>
+            </a:extLst>
+          </p:cNvPr>
+          <p:cNvSpPr txBox="1"/>
+          <p:nvPr/>
+        </p:nvSpPr>
+        <p:spPr>
+          <a:xfrm>
+            <a:off x="-1" y="6488668"/>
+            <a:ext cx="12192000" cy="338554"/>
+          </a:xfrm>
+          <a:prstGeom prst="rect">
+            <a:avLst/>
+          </a:prstGeom>
+          <a:noFill/>
+        </p:spPr>
+        <p:txBody>
+          <a:bodyPr wrap="square" rtlCol="0">
+            <a:spAutoFit/>
+          </a:bodyPr>
+          <a:lstStyle/>
+          <a:p>
+            <a:pPr algn="ctr"/>
+            <a:r>
+              <a:rPr lang="fr-FR" sz="1600" dirty="0">
+                <a:solidFill>
+                  <a:schemeClr val="bg1">
+                    <a:lumMod val="85000"/>
+                  </a:schemeClr>
+                </a:solidFill>
+              </a:rPr>
+              <a:t>Introduction</a:t>
+            </a:r>
+            <a:r>
+              <a:rPr lang="fr-FR" sz="1600" dirty="0"/>
+              <a:t> </a:t>
+            </a:r>
+            <a:r>
+              <a:rPr lang="fr-FR" sz="1600" dirty="0">
+                <a:solidFill>
+                  <a:schemeClr val="bg1">
+                    <a:lumMod val="85000"/>
+                  </a:schemeClr>
+                </a:solidFill>
+                <a:sym typeface="Wingdings" panose="05000000000000000000" pitchFamily="2" charset="2"/>
+              </a:rPr>
+              <a:t> Description  </a:t>
+            </a:r>
+            <a:r>
+              <a:rPr lang="fr-FR" sz="1600" dirty="0">
+                <a:solidFill>
+                  <a:schemeClr val="bg1">
+                    <a:lumMod val="85000"/>
+                  </a:schemeClr>
+                </a:solidFill>
+              </a:rPr>
+              <a:t>Analyses </a:t>
+            </a:r>
+            <a:r>
+              <a:rPr lang="fr-FR" sz="1600" dirty="0">
+                <a:solidFill>
+                  <a:schemeClr val="bg1">
+                    <a:lumMod val="85000"/>
+                  </a:schemeClr>
+                </a:solidFill>
+                <a:sym typeface="Wingdings" panose="05000000000000000000" pitchFamily="2" charset="2"/>
+              </a:rPr>
+              <a:t> </a:t>
+            </a:r>
+            <a:r>
+              <a:rPr lang="fr-FR" sz="1600" dirty="0" err="1">
+                <a:solidFill>
+                  <a:schemeClr val="bg1">
+                    <a:lumMod val="85000"/>
+                  </a:schemeClr>
+                </a:solidFill>
+                <a:sym typeface="Wingdings" panose="05000000000000000000" pitchFamily="2" charset="2"/>
+              </a:rPr>
+              <a:t>Feature</a:t>
+            </a:r>
+            <a:r>
+              <a:rPr lang="fr-FR" sz="1600" dirty="0">
+                <a:solidFill>
+                  <a:schemeClr val="bg1">
+                    <a:lumMod val="85000"/>
+                  </a:schemeClr>
+                </a:solidFill>
+                <a:sym typeface="Wingdings" panose="05000000000000000000" pitchFamily="2" charset="2"/>
+              </a:rPr>
+              <a:t> engineering  Modélisation </a:t>
+            </a:r>
+            <a:r>
+              <a:rPr lang="fr-FR" sz="1600" dirty="0" err="1">
+                <a:solidFill>
+                  <a:schemeClr val="bg1">
+                    <a:lumMod val="85000"/>
+                  </a:schemeClr>
+                </a:solidFill>
+                <a:sym typeface="Wingdings" panose="05000000000000000000" pitchFamily="2" charset="2"/>
+              </a:rPr>
+              <a:t>Feature</a:t>
+            </a:r>
+            <a:r>
+              <a:rPr lang="fr-FR" sz="1600" dirty="0">
+                <a:solidFill>
+                  <a:schemeClr val="bg1">
+                    <a:lumMod val="85000"/>
+                  </a:schemeClr>
+                </a:solidFill>
+                <a:sym typeface="Wingdings" panose="05000000000000000000" pitchFamily="2" charset="2"/>
+              </a:rPr>
+              <a:t> importance  Déploiement  Suivi  </a:t>
+            </a:r>
+            <a:r>
+              <a:rPr lang="fr-FR" sz="1600" dirty="0">
+                <a:sym typeface="Wingdings" panose="05000000000000000000" pitchFamily="2" charset="2"/>
+              </a:rPr>
+              <a:t>Exemple</a:t>
+            </a:r>
+            <a:endParaRPr lang="fr-FR" sz="1600" dirty="0"/>
+          </a:p>
+        </p:txBody>
+      </p:sp>
+    </p:spTree>
+    <p:extLst>
+      <p:ext uri="{BB962C8B-B14F-4D97-AF65-F5344CB8AC3E}">
+        <p14:creationId xmlns:p14="http://schemas.microsoft.com/office/powerpoint/2010/main" val="1535257299"/>
       </p:ext>
     </p:extLst>
   </p:cSld>

</xml_diff>